<commit_message>
Embed real screenshots into meeting slide deck (16 slides)
Added 4 showcase slides with 8 existing screenshots (docs/screens): public web (home, match detail, rankings, sponsorship) and admin (dashboard, AI ingest review, content, ads). Newest screens (seasons/notifications/audit/detail forms) not yet captured — pending Playwright reconnect.

Co-Authored-By: Claude Opus 4.8 <noreply@anthropic.com>
</commit_message>
<xml_diff>
--- a/docs/VSP-사업계획-슬라이드.pptx
+++ b/docs/VSP-사업계획-슬라이드.pptx
@@ -17,6 +17,10 @@
     <p:sldId id="265" r:id="rId16"/>
     <p:sldId id="266" r:id="rId17"/>
     <p:sldId id="267" r:id="rId18"/>
+    <p:sldId id="268" r:id="rId19"/>
+    <p:sldId id="269" r:id="rId20"/>
+    <p:sldId id="270" r:id="rId21"/>
+    <p:sldId id="271" r:id="rId22"/>
   </p:sldIdLst>
   <p:sldSz cx="12191695" cy="6858000" type="screen4x3"/>
   <p:notesSz cx="6858000" cy="9144000"/>
@@ -3277,8 +3281,8 @@
         </p:nvSpPr>
         <p:spPr>
           <a:xfrm>
-            <a:off x="548640" y="411480"/>
-            <a:ext cx="11155680" cy="1051560"/>
+            <a:off x="548640" y="365760"/>
+            <a:ext cx="11155680" cy="914400"/>
           </a:xfrm>
           <a:prstGeom prst="rect">
             <a:avLst/>
@@ -3292,36 +3296,60 @@
           <a:lstStyle/>
           <a:p>
             <a:r>
-              <a:rPr sz="2800" b="1">
+              <a:rPr sz="2600" b="1">
                 <a:solidFill>
                   <a:srgbClr val="15607A"/>
                 </a:solidFill>
               </a:rPr>
-              <a:t>Chương trình họp &amp; câu hỏi quyết định</a:t>
-            </a:r>
-          </a:p>
-          <a:p>
-            <a:r>
-              <a:rPr sz="1700" b="1">
+              <a:t>Màn hình thực tế — Khu nghiệp vụ (2)</a:t>
+            </a:r>
+          </a:p>
+          <a:p>
+            <a:r>
+              <a:rPr sz="1500" b="1">
                 <a:solidFill>
                   <a:srgbClr val="6A7C8A"/>
                 </a:solidFill>
               </a:rPr>
-              <a:t>미팅 안건·확인 질문</a:t>
-            </a:r>
-          </a:p>
-        </p:txBody>
-      </p:sp>
-      <p:sp>
-        <p:nvSpPr>
-          <p:cNvPr id="4" name="TextBox 3"/>
+              <a:t>실제 화면 — 업무 (2)</a:t>
+            </a:r>
+          </a:p>
+        </p:txBody>
+      </p:sp>
+      <p:pic>
+        <p:nvPicPr>
+          <p:cNvPr id="4" name="Picture 3" descr="11-admin-content.png"/>
+          <p:cNvPicPr>
+            <a:picLocks noChangeAspect="1"/>
+          </p:cNvPicPr>
+          <p:nvPr/>
+        </p:nvPicPr>
+        <p:blipFill>
+          <a:blip r:embed="rId2"/>
+          <a:stretch>
+            <a:fillRect/>
+          </a:stretch>
+        </p:blipFill>
+        <p:spPr>
+          <a:xfrm>
+            <a:off x="571500" y="1554480"/>
+            <a:ext cx="5349240" cy="3343275"/>
+          </a:xfrm>
+          <a:prstGeom prst="rect">
+            <a:avLst/>
+          </a:prstGeom>
+        </p:spPr>
+      </p:pic>
+      <p:sp>
+        <p:nvSpPr>
+          <p:cNvPr id="5" name="TextBox 4"/>
           <p:cNvSpPr txBox="1"/>
           <p:nvPr/>
         </p:nvSpPr>
         <p:spPr>
           <a:xfrm>
-            <a:off x="685800" y="1691640"/>
-            <a:ext cx="10881360" cy="4480560"/>
+            <a:off x="457200" y="5806440"/>
+            <a:ext cx="5577840" cy="777240"/>
           </a:xfrm>
           <a:prstGeom prst="rect">
             <a:avLst/>
@@ -3334,118 +3362,94 @@
           </a:bodyPr>
           <a:lstStyle/>
           <a:p>
-            <a:pPr>
-              <a:spcAft>
-                <a:spcPts val="900"/>
-              </a:spcAft>
-            </a:pPr>
-            <a:r>
-              <a:rPr sz="1700">
+            <a:pPr algn="ctr"/>
+            <a:r>
+              <a:rPr sz="1300" b="1">
                 <a:solidFill>
                   <a:srgbClr val="1F2933"/>
                 </a:solidFill>
               </a:rPr>
-              <a:t>▪ Kết nối hệ thống quốc gia đến đâu?</a:t>
-            </a:r>
-            <a:r>
-              <a:rPr sz="1500">
+              <a:t>Nội dung·bài viết</a:t>
+            </a:r>
+          </a:p>
+          <a:p>
+            <a:pPr algn="ctr"/>
+            <a:r>
+              <a:rPr sz="1100">
                 <a:solidFill>
                   <a:srgbClr val="455562"/>
                 </a:solidFill>
               </a:rPr>
-              <a:t>   /  국가 시스템 연동 범위?</a:t>
-            </a:r>
-          </a:p>
-          <a:p>
-            <a:pPr>
-              <a:spcAft>
-                <a:spcPts val="900"/>
-              </a:spcAft>
-            </a:pPr>
-            <a:r>
-              <a:rPr sz="1700">
+              <a:t>콘텐츠·기사</a:t>
+            </a:r>
+          </a:p>
+        </p:txBody>
+      </p:sp>
+      <p:pic>
+        <p:nvPicPr>
+          <p:cNvPr id="6" name="Picture 5" descr="13-admin-ads.png"/>
+          <p:cNvPicPr>
+            <a:picLocks noChangeAspect="1"/>
+          </p:cNvPicPr>
+          <p:nvPr/>
+        </p:nvPicPr>
+        <p:blipFill>
+          <a:blip r:embed="rId3"/>
+          <a:stretch>
+            <a:fillRect/>
+          </a:stretch>
+        </p:blipFill>
+        <p:spPr>
+          <a:xfrm>
+            <a:off x="6423660" y="1554480"/>
+            <a:ext cx="5349240" cy="3343275"/>
+          </a:xfrm>
+          <a:prstGeom prst="rect">
+            <a:avLst/>
+          </a:prstGeom>
+        </p:spPr>
+      </p:pic>
+      <p:sp>
+        <p:nvSpPr>
+          <p:cNvPr id="7" name="TextBox 6"/>
+          <p:cNvSpPr txBox="1"/>
+          <p:nvPr/>
+        </p:nvSpPr>
+        <p:spPr>
+          <a:xfrm>
+            <a:off x="6309360" y="5806440"/>
+            <a:ext cx="5577840" cy="777240"/>
+          </a:xfrm>
+          <a:prstGeom prst="rect">
+            <a:avLst/>
+          </a:prstGeom>
+          <a:noFill/>
+        </p:spPr>
+        <p:txBody>
+          <a:bodyPr wrap="square">
+            <a:spAutoFit/>
+          </a:bodyPr>
+          <a:lstStyle/>
+          <a:p>
+            <a:pPr algn="ctr"/>
+            <a:r>
+              <a:rPr sz="1300" b="1">
                 <a:solidFill>
                   <a:srgbClr val="1F2933"/>
                 </a:solidFill>
               </a:rPr>
-              <a:t>▪ Chốt luồng phê duyệt·báo cáo nội bộ?</a:t>
-            </a:r>
-            <a:r>
-              <a:rPr sz="1500">
+              <a:t>Quảng cáo</a:t>
+            </a:r>
+          </a:p>
+          <a:p>
+            <a:pPr algn="ctr"/>
+            <a:r>
+              <a:rPr sz="1100">
                 <a:solidFill>
                   <a:srgbClr val="455562"/>
                 </a:solidFill>
               </a:rPr>
-              <a:t>   /  내부 결재·보고 체계 확정?</a:t>
-            </a:r>
-          </a:p>
-          <a:p>
-            <a:pPr>
-              <a:spcAft>
-                <a:spcPts val="900"/>
-              </a:spcAft>
-            </a:pPr>
-            <a:r>
-              <a:rPr sz="1700">
-                <a:solidFill>
-                  <a:srgbClr val="1F2933"/>
-                </a:solidFill>
-              </a:rPr>
-              <a:t>▪ Ai đăng ký VĐV — bản thân hay tổ chức?</a:t>
-            </a:r>
-            <a:r>
-              <a:rPr sz="1500">
-                <a:solidFill>
-                  <a:srgbClr val="455562"/>
-                </a:solidFill>
-              </a:rPr>
-              <a:t>   /  경기인 등록 주체 — 본인 vs 단체?</a:t>
-            </a:r>
-          </a:p>
-          <a:p>
-            <a:pPr>
-              <a:spcAft>
-                <a:spcPts val="900"/>
-              </a:spcAft>
-            </a:pPr>
-            <a:r>
-              <a:rPr sz="1700">
-                <a:solidFill>
-                  <a:srgbClr val="1F2933"/>
-                </a:solidFill>
-              </a:rPr>
-              <a:t>▪ Căn cứ hiệu lực chữ ký điện tử?</a:t>
-            </a:r>
-            <a:r>
-              <a:rPr sz="1500">
-                <a:solidFill>
-                  <a:srgbClr val="455562"/>
-                </a:solidFill>
-              </a:rPr>
-              <a:t>   /  전자서명 효력 근거?</a:t>
-            </a:r>
-          </a:p>
-          <a:p>
-            <a:pPr>
-              <a:spcAft>
-                <a:spcPts val="900"/>
-              </a:spcAft>
-            </a:pPr>
-            <a:r>
-              <a:rPr sz="1700">
-                <a:solidFill>
-                  <a:srgbClr val="1F2933"/>
-                </a:solidFill>
-              </a:rPr>
-              <a:t>▪ Phạm vi pilot ban đầu (môn·địa phương)?</a:t>
-            </a:r>
-            <a:r>
-              <a:rPr sz="1500">
-                <a:solidFill>
-                  <a:srgbClr val="455562"/>
-                </a:solidFill>
-              </a:rPr>
-              <a:t>   /  초기 파일럿 범위(종목·지역)?</a:t>
+              <a:t>광고 지면</a:t>
             </a:r>
           </a:p>
         </p:txBody>
@@ -3547,7 +3551,7 @@
                   <a:srgbClr val="15607A"/>
                 </a:solidFill>
               </a:rPr>
-              <a:t>Doanh thu · Rủi ro &amp; ứng phó</a:t>
+              <a:t>Kiến trúc, bảo mật &amp; tuân thủ pháp luật</a:t>
             </a:r>
           </a:p>
           <a:p>
@@ -3557,7 +3561,7 @@
                   <a:srgbClr val="6A7C8A"/>
                 </a:solidFill>
               </a:rPr>
-              <a:t>수익 구조 · 리스크 대응</a:t>
+              <a:t>시스템·보안·법규 준수</a:t>
             </a:r>
           </a:p>
         </p:txBody>
@@ -3595,7 +3599,7 @@
                   <a:srgbClr val="1F2933"/>
                 </a:solidFill>
               </a:rPr>
-              <a:t>▪ Doanh thu: phí hệ thống·quảng cáo/tài trợ·dịch vụ giá trị gia tăng (không trung gian dòng tiền)</a:t>
+              <a:t>▪ Tách dữ liệu công khai/nghiệp vụ (pub + vai trò chỉ-đọc)</a:t>
             </a:r>
             <a:r>
               <a:rPr sz="1500">
@@ -3603,7 +3607,7 @@
                   <a:srgbClr val="455562"/>
                 </a:solidFill>
               </a:rPr>
-              <a:t>   /  수익: 시스템 이용료·광고/후원·부가서비스(자금 미경유)</a:t>
+              <a:t>   /  대외/업무 데이터 분리(pub+읽기전용 롤)</a:t>
             </a:r>
           </a:p>
           <a:p>
@@ -3618,7 +3622,7 @@
                   <a:srgbClr val="1F2933"/>
                 </a:solidFill>
               </a:rPr>
-              <a:t>▪ Rủi ro biểu mẫu chậm → đề nghị ngay·chuẩn bị song song</a:t>
+              <a:t>▪ Bảo vệ dữ liệu cá nhân (NĐ 13/2023): năm sinh·trẻ vị thành niên·băm giấy tờ</a:t>
             </a:r>
             <a:r>
               <a:rPr sz="1500">
@@ -3626,7 +3630,7 @@
                   <a:srgbClr val="455562"/>
                 </a:solidFill>
               </a:rPr>
-              <a:t>   /  서식 지연 → 즉시 요청·병렬 준비</a:t>
+              <a:t>   /  개인정보(13/2023): 출생연도·미성년·신분증 해시</a:t>
             </a:r>
           </a:p>
           <a:p>
@@ -3641,7 +3645,7 @@
                   <a:srgbClr val="1F2933"/>
                 </a:solidFill>
               </a:rPr>
-              <a:t>▪ Rủi ro pháp lý → cổng rà soát trước pilot</a:t>
+              <a:t>▪ Nội địa hóa dữ liệu (NĐ 53/2022): máy chủ trong nước</a:t>
             </a:r>
             <a:r>
               <a:rPr sz="1500">
@@ -3649,7 +3653,7 @@
                   <a:srgbClr val="455562"/>
                 </a:solidFill>
               </a:rPr>
-              <a:t>   /  법률 리스크 → 파일럿 전 검토 게이트</a:t>
+              <a:t>   /  데이터 현지화(53/2022): 국내 서버</a:t>
             </a:r>
           </a:p>
           <a:p>
@@ -3664,7 +3668,7 @@
                   <a:srgbClr val="1F2933"/>
                 </a:solidFill>
               </a:rPr>
-              <a:t>▪ Rủi ro chấp nhận → kiểm chứng bằng pilot</a:t>
+              <a:t>▪ Thanh toán (NĐ 52/2024): tiền không qua tài khoản chúng tôi</a:t>
             </a:r>
             <a:r>
               <a:rPr sz="1500">
@@ -3672,7 +3676,30 @@
                   <a:srgbClr val="455562"/>
                 </a:solidFill>
               </a:rPr>
-              <a:t>   /  채택 리스크 → 파일럿으로 검증</a:t>
+              <a:t>   /  결제(52/2024): 자금 우리 계좌 미경유</a:t>
+            </a:r>
+          </a:p>
+          <a:p>
+            <a:pPr>
+              <a:spcAft>
+                <a:spcPts val="900"/>
+              </a:spcAft>
+            </a:pPr>
+            <a:r>
+              <a:rPr sz="1700">
+                <a:solidFill>
+                  <a:srgbClr val="1F2933"/>
+                </a:solidFill>
+              </a:rPr>
+              <a:t>▪ Xác nhận hiệu lực chữ ký điện tử của phê duyệt</a:t>
+            </a:r>
+            <a:r>
+              <a:rPr sz="1500">
+                <a:solidFill>
+                  <a:srgbClr val="455562"/>
+                </a:solidFill>
+              </a:rPr>
+              <a:t>   /  전자결재 법적 효력 근거 확인</a:t>
             </a:r>
           </a:p>
         </p:txBody>
@@ -3774,6 +3801,983 @@
                   <a:srgbClr val="15607A"/>
                 </a:solidFill>
               </a:rPr>
+              <a:t>Điều kiện vận hành: 4 cửa &amp; lộ trình</a:t>
+            </a:r>
+          </a:p>
+          <a:p>
+            <a:r>
+              <a:rPr sz="1700" b="1">
+                <a:solidFill>
+                  <a:srgbClr val="6A7C8A"/>
+                </a:solidFill>
+              </a:rPr>
+              <a:t>실사용: 4관문 &amp; 로드맵</a:t>
+            </a:r>
+          </a:p>
+        </p:txBody>
+      </p:sp>
+      <p:sp>
+        <p:nvSpPr>
+          <p:cNvPr id="4" name="TextBox 3"/>
+          <p:cNvSpPr txBox="1"/>
+          <p:nvPr/>
+        </p:nvSpPr>
+        <p:spPr>
+          <a:xfrm>
+            <a:off x="685800" y="1691640"/>
+            <a:ext cx="10881360" cy="4480560"/>
+          </a:xfrm>
+          <a:prstGeom prst="rect">
+            <a:avLst/>
+          </a:prstGeom>
+          <a:noFill/>
+        </p:spPr>
+        <p:txBody>
+          <a:bodyPr wrap="square">
+            <a:spAutoFit/>
+          </a:bodyPr>
+          <a:lstStyle/>
+          <a:p>
+            <a:pPr>
+              <a:spcAft>
+                <a:spcPts val="900"/>
+              </a:spcAft>
+            </a:pPr>
+            <a:r>
+              <a:rPr sz="1700">
+                <a:solidFill>
+                  <a:srgbClr val="1F2933"/>
+                </a:solidFill>
+              </a:rPr>
+              <a:t>▪ Cửa 1 Pháp lý · Cửa 2 Dữ liệu/biểu mẫu · Cửa 3 Hạ tầng/khóa · Cửa 4 Vận hành</a:t>
+            </a:r>
+            <a:r>
+              <a:rPr sz="1500">
+                <a:solidFill>
+                  <a:srgbClr val="455562"/>
+                </a:solidFill>
+              </a:rPr>
+              <a:t>   /  관문1 법·2 데이터/서식·3 인프라/키·4 운영</a:t>
+            </a:r>
+          </a:p>
+          <a:p>
+            <a:pPr>
+              <a:spcAft>
+                <a:spcPts val="900"/>
+              </a:spcAft>
+            </a:pPr>
+            <a:r>
+              <a:rPr sz="1700">
+                <a:solidFill>
+                  <a:srgbClr val="1F2933"/>
+                </a:solidFill>
+              </a:rPr>
+              <a:t>▪ P0 Họp(nay): demo·câu hỏi quyết định</a:t>
+            </a:r>
+            <a:r>
+              <a:rPr sz="1500">
+                <a:solidFill>
+                  <a:srgbClr val="455562"/>
+                </a:solidFill>
+              </a:rPr>
+              <a:t>   /  P0 미팅(지금): 데모·확인질문</a:t>
+            </a:r>
+          </a:p>
+          <a:p>
+            <a:pPr>
+              <a:spcAft>
+                <a:spcPts val="900"/>
+              </a:spcAft>
+            </a:pPr>
+            <a:r>
+              <a:rPr sz="1700">
+                <a:solidFill>
+                  <a:srgbClr val="1F2933"/>
+                </a:solidFill>
+              </a:rPr>
+              <a:t>▪ P1 (1–2 tuần): phản ánh biểu mẫu·nạp khóa·staging VN·diễn tập</a:t>
+            </a:r>
+            <a:r>
+              <a:rPr sz="1500">
+                <a:solidFill>
+                  <a:srgbClr val="455562"/>
+                </a:solidFill>
+              </a:rPr>
+              <a:t>   /  P1(1–2주): 서식반영·키·VN 스테이징·리허설</a:t>
+            </a:r>
+          </a:p>
+          <a:p>
+            <a:pPr>
+              <a:spcAft>
+                <a:spcPts val="900"/>
+              </a:spcAft>
+            </a:pPr>
+            <a:r>
+              <a:rPr sz="1700">
+                <a:solidFill>
+                  <a:srgbClr val="1F2933"/>
+                </a:solidFill>
+              </a:rPr>
+              <a:t>▪ P2 (4–8 tuần): pilot 1 môn·1 địa phương → qua cổng pháp lý</a:t>
+            </a:r>
+            <a:r>
+              <a:rPr sz="1500">
+                <a:solidFill>
+                  <a:srgbClr val="455562"/>
+                </a:solidFill>
+              </a:rPr>
+              <a:t>   /  P2(4–8주): 1종목·1지역 파일럿 → 법률 게이트 통과</a:t>
+            </a:r>
+          </a:p>
+          <a:p>
+            <a:pPr>
+              <a:spcAft>
+                <a:spcPts val="900"/>
+              </a:spcAft>
+            </a:pPr>
+            <a:r>
+              <a:rPr sz="1700">
+                <a:solidFill>
+                  <a:srgbClr val="1F2933"/>
+                </a:solidFill>
+              </a:rPr>
+              <a:t>▪ P3: mở rộng toàn quốc·toàn môn·mở cổng công khai</a:t>
+            </a:r>
+            <a:r>
+              <a:rPr sz="1500">
+                <a:solidFill>
+                  <a:srgbClr val="455562"/>
+                </a:solidFill>
+              </a:rPr>
+              <a:t>   /  P3: 전국·전종목·공개 확대</a:t>
+            </a:r>
+          </a:p>
+        </p:txBody>
+      </p:sp>
+    </p:spTree>
+  </p:cSld>
+  <p:clrMapOvr>
+    <a:masterClrMapping/>
+  </p:clrMapOvr>
+</p:sld>
+</file>
+
+<file path=ppt/slides/slide13.xml><?xml version="1.0" encoding="utf-8"?>
+<p:sld xmlns:a="http://schemas.openxmlformats.org/drawingml/2006/main" xmlns:p="http://schemas.openxmlformats.org/presentationml/2006/main" xmlns:r="http://schemas.openxmlformats.org/officeDocument/2006/relationships">
+  <p:cSld>
+    <p:bg>
+      <p:bgPr>
+        <a:solidFill>
+          <a:srgbClr val="F4F6F8"/>
+        </a:solidFill>
+        <a:effectLst/>
+      </p:bgPr>
+    </p:bg>
+    <p:spTree>
+      <p:nvGrpSpPr>
+        <p:cNvPr id="1" name=""/>
+        <p:cNvGrpSpPr/>
+        <p:nvPr/>
+      </p:nvGrpSpPr>
+      <p:grpSpPr/>
+      <p:sp>
+        <p:nvSpPr>
+          <p:cNvPr id="2" name="Rectangle 1"/>
+          <p:cNvSpPr/>
+          <p:nvPr/>
+        </p:nvSpPr>
+        <p:spPr>
+          <a:xfrm>
+            <a:off x="0" y="0"/>
+            <a:ext cx="128016" cy="6858000"/>
+          </a:xfrm>
+          <a:prstGeom prst="rect">
+            <a:avLst/>
+          </a:prstGeom>
+          <a:solidFill>
+            <a:srgbClr val="15607A"/>
+          </a:solidFill>
+          <a:ln>
+            <a:noFill/>
+          </a:ln>
+        </p:spPr>
+        <p:style>
+          <a:lnRef idx="1">
+            <a:schemeClr val="accent1"/>
+          </a:lnRef>
+          <a:fillRef idx="3">
+            <a:schemeClr val="accent1"/>
+          </a:fillRef>
+          <a:effectRef idx="2">
+            <a:schemeClr val="accent1"/>
+          </a:effectRef>
+          <a:fontRef idx="minor">
+            <a:schemeClr val="lt1"/>
+          </a:fontRef>
+        </p:style>
+        <p:txBody>
+          <a:bodyPr rtlCol="0" anchor="ctr"/>
+          <a:lstStyle/>
+          <a:p>
+            <a:pPr algn="ctr"/>
+          </a:p>
+        </p:txBody>
+      </p:sp>
+      <p:sp>
+        <p:nvSpPr>
+          <p:cNvPr id="3" name="TextBox 2"/>
+          <p:cNvSpPr txBox="1"/>
+          <p:nvPr/>
+        </p:nvSpPr>
+        <p:spPr>
+          <a:xfrm>
+            <a:off x="548640" y="411480"/>
+            <a:ext cx="11155680" cy="1051560"/>
+          </a:xfrm>
+          <a:prstGeom prst="rect">
+            <a:avLst/>
+          </a:prstGeom>
+          <a:noFill/>
+        </p:spPr>
+        <p:txBody>
+          <a:bodyPr wrap="square">
+            <a:spAutoFit/>
+          </a:bodyPr>
+          <a:lstStyle/>
+          <a:p>
+            <a:r>
+              <a:rPr sz="2800" b="1">
+                <a:solidFill>
+                  <a:srgbClr val="15607A"/>
+                </a:solidFill>
+              </a:rPr>
+              <a:t>Đề nghị với Bộ VHTTDL / Cục TDTT</a:t>
+            </a:r>
+          </a:p>
+          <a:p>
+            <a:r>
+              <a:rPr sz="1700" b="1">
+                <a:solidFill>
+                  <a:srgbClr val="6A7C8A"/>
+                </a:solidFill>
+              </a:rPr>
+              <a:t>문체부·체육회 요청 (미팅 핵심)</a:t>
+            </a:r>
+          </a:p>
+        </p:txBody>
+      </p:sp>
+      <p:sp>
+        <p:nvSpPr>
+          <p:cNvPr id="4" name="TextBox 3"/>
+          <p:cNvSpPr txBox="1"/>
+          <p:nvPr/>
+        </p:nvSpPr>
+        <p:spPr>
+          <a:xfrm>
+            <a:off x="685800" y="1691640"/>
+            <a:ext cx="10881360" cy="4480560"/>
+          </a:xfrm>
+          <a:prstGeom prst="rect">
+            <a:avLst/>
+          </a:prstGeom>
+          <a:noFill/>
+        </p:spPr>
+        <p:txBody>
+          <a:bodyPr wrap="square">
+            <a:spAutoFit/>
+          </a:bodyPr>
+          <a:lstStyle/>
+          <a:p>
+            <a:pPr>
+              <a:spcAft>
+                <a:spcPts val="900"/>
+              </a:spcAft>
+            </a:pPr>
+            <a:r>
+              <a:rPr sz="1700">
+                <a:solidFill>
+                  <a:srgbClr val="1F2933"/>
+                </a:solidFill>
+              </a:rPr>
+              <a:t>▪ Biểu mẫu chính thức (Word/Excel) — nút thắt LỚN NHẤT</a:t>
+            </a:r>
+            <a:r>
+              <a:rPr sz="1500">
+                <a:solidFill>
+                  <a:srgbClr val="455562"/>
+                </a:solidFill>
+              </a:rPr>
+              <a:t>   /  공식 서식(Word/Excel) — 최대 병목</a:t>
+            </a:r>
+          </a:p>
+          <a:p>
+            <a:pPr>
+              <a:spcAft>
+                <a:spcPts val="900"/>
+              </a:spcAft>
+            </a:pPr>
+            <a:r>
+              <a:rPr sz="1700">
+                <a:solidFill>
+                  <a:srgbClr val="1F2933"/>
+                </a:solidFill>
+              </a:rPr>
+              <a:t>▪ 34 mã tỉnh/thành hành chính chính thức</a:t>
+            </a:r>
+            <a:r>
+              <a:rPr sz="1500">
+                <a:solidFill>
+                  <a:srgbClr val="455562"/>
+                </a:solidFill>
+              </a:rPr>
+              <a:t>   /  공식 34개 성/시 코드</a:t>
+            </a:r>
+          </a:p>
+          <a:p>
+            <a:pPr>
+              <a:spcAft>
+                <a:spcPts val="900"/>
+              </a:spcAft>
+            </a:pPr>
+            <a:r>
+              <a:rPr sz="1700">
+                <a:solidFill>
+                  <a:srgbClr val="1F2933"/>
+                </a:solidFill>
+              </a:rPr>
+              <a:t>▪ Luồng phê duyệt &amp; thời hạn pháp định theo thủ tục</a:t>
+            </a:r>
+            <a:r>
+              <a:rPr sz="1500">
+                <a:solidFill>
+                  <a:srgbClr val="455562"/>
+                </a:solidFill>
+              </a:rPr>
+              <a:t>   /  절차별 결재선·법정기한</a:t>
+            </a:r>
+          </a:p>
+          <a:p>
+            <a:pPr>
+              <a:spcAft>
+                <a:spcPts val="900"/>
+              </a:spcAft>
+            </a:pPr>
+            <a:r>
+              <a:rPr sz="1700">
+                <a:solidFill>
+                  <a:srgbClr val="1F2933"/>
+                </a:solidFill>
+              </a:rPr>
+              <a:t>▪ Phạm vi kết nối hệ thống QG (DVC·VNeID·văn bản/chữ ký)</a:t>
+            </a:r>
+            <a:r>
+              <a:rPr sz="1500">
+                <a:solidFill>
+                  <a:srgbClr val="455562"/>
+                </a:solidFill>
+              </a:rPr>
+              <a:t>   /  국가시스템 연동 범위(포털·VNeID·전자문서)</a:t>
+            </a:r>
+          </a:p>
+          <a:p>
+            <a:pPr>
+              <a:spcAft>
+                <a:spcPts val="900"/>
+              </a:spcAft>
+            </a:pPr>
+            <a:r>
+              <a:rPr sz="1700">
+                <a:solidFill>
+                  <a:srgbClr val="1F2933"/>
+                </a:solidFill>
+              </a:rPr>
+              <a:t>▪ Căn cứ pháp lý: chữ ký điện tử·dữ liệu·thanh toán</a:t>
+            </a:r>
+            <a:r>
+              <a:rPr sz="1500">
+                <a:solidFill>
+                  <a:srgbClr val="455562"/>
+                </a:solidFill>
+              </a:rPr>
+              <a:t>   /  법적 근거: 전자서명·개인정보·결제</a:t>
+            </a:r>
+          </a:p>
+        </p:txBody>
+      </p:sp>
+    </p:spTree>
+  </p:cSld>
+  <p:clrMapOvr>
+    <a:masterClrMapping/>
+  </p:clrMapOvr>
+</p:sld>
+</file>
+
+<file path=ppt/slides/slide14.xml><?xml version="1.0" encoding="utf-8"?>
+<p:sld xmlns:a="http://schemas.openxmlformats.org/drawingml/2006/main" xmlns:p="http://schemas.openxmlformats.org/presentationml/2006/main" xmlns:r="http://schemas.openxmlformats.org/officeDocument/2006/relationships">
+  <p:cSld>
+    <p:bg>
+      <p:bgPr>
+        <a:solidFill>
+          <a:srgbClr val="F4F6F8"/>
+        </a:solidFill>
+        <a:effectLst/>
+      </p:bgPr>
+    </p:bg>
+    <p:spTree>
+      <p:nvGrpSpPr>
+        <p:cNvPr id="1" name=""/>
+        <p:cNvGrpSpPr/>
+        <p:nvPr/>
+      </p:nvGrpSpPr>
+      <p:grpSpPr/>
+      <p:sp>
+        <p:nvSpPr>
+          <p:cNvPr id="2" name="Rectangle 1"/>
+          <p:cNvSpPr/>
+          <p:nvPr/>
+        </p:nvSpPr>
+        <p:spPr>
+          <a:xfrm>
+            <a:off x="0" y="0"/>
+            <a:ext cx="128016" cy="6858000"/>
+          </a:xfrm>
+          <a:prstGeom prst="rect">
+            <a:avLst/>
+          </a:prstGeom>
+          <a:solidFill>
+            <a:srgbClr val="15607A"/>
+          </a:solidFill>
+          <a:ln>
+            <a:noFill/>
+          </a:ln>
+        </p:spPr>
+        <p:style>
+          <a:lnRef idx="1">
+            <a:schemeClr val="accent1"/>
+          </a:lnRef>
+          <a:fillRef idx="3">
+            <a:schemeClr val="accent1"/>
+          </a:fillRef>
+          <a:effectRef idx="2">
+            <a:schemeClr val="accent1"/>
+          </a:effectRef>
+          <a:fontRef idx="minor">
+            <a:schemeClr val="lt1"/>
+          </a:fontRef>
+        </p:style>
+        <p:txBody>
+          <a:bodyPr rtlCol="0" anchor="ctr"/>
+          <a:lstStyle/>
+          <a:p>
+            <a:pPr algn="ctr"/>
+          </a:p>
+        </p:txBody>
+      </p:sp>
+      <p:sp>
+        <p:nvSpPr>
+          <p:cNvPr id="3" name="TextBox 2"/>
+          <p:cNvSpPr txBox="1"/>
+          <p:nvPr/>
+        </p:nvSpPr>
+        <p:spPr>
+          <a:xfrm>
+            <a:off x="548640" y="411480"/>
+            <a:ext cx="11155680" cy="1051560"/>
+          </a:xfrm>
+          <a:prstGeom prst="rect">
+            <a:avLst/>
+          </a:prstGeom>
+          <a:noFill/>
+        </p:spPr>
+        <p:txBody>
+          <a:bodyPr wrap="square">
+            <a:spAutoFit/>
+          </a:bodyPr>
+          <a:lstStyle/>
+          <a:p>
+            <a:r>
+              <a:rPr sz="2800" b="1">
+                <a:solidFill>
+                  <a:srgbClr val="15607A"/>
+                </a:solidFill>
+              </a:rPr>
+              <a:t>Chương trình họp &amp; câu hỏi quyết định</a:t>
+            </a:r>
+          </a:p>
+          <a:p>
+            <a:r>
+              <a:rPr sz="1700" b="1">
+                <a:solidFill>
+                  <a:srgbClr val="6A7C8A"/>
+                </a:solidFill>
+              </a:rPr>
+              <a:t>미팅 안건·확인 질문</a:t>
+            </a:r>
+          </a:p>
+        </p:txBody>
+      </p:sp>
+      <p:sp>
+        <p:nvSpPr>
+          <p:cNvPr id="4" name="TextBox 3"/>
+          <p:cNvSpPr txBox="1"/>
+          <p:nvPr/>
+        </p:nvSpPr>
+        <p:spPr>
+          <a:xfrm>
+            <a:off x="685800" y="1691640"/>
+            <a:ext cx="10881360" cy="4480560"/>
+          </a:xfrm>
+          <a:prstGeom prst="rect">
+            <a:avLst/>
+          </a:prstGeom>
+          <a:noFill/>
+        </p:spPr>
+        <p:txBody>
+          <a:bodyPr wrap="square">
+            <a:spAutoFit/>
+          </a:bodyPr>
+          <a:lstStyle/>
+          <a:p>
+            <a:pPr>
+              <a:spcAft>
+                <a:spcPts val="900"/>
+              </a:spcAft>
+            </a:pPr>
+            <a:r>
+              <a:rPr sz="1700">
+                <a:solidFill>
+                  <a:srgbClr val="1F2933"/>
+                </a:solidFill>
+              </a:rPr>
+              <a:t>▪ Kết nối hệ thống quốc gia đến đâu?</a:t>
+            </a:r>
+            <a:r>
+              <a:rPr sz="1500">
+                <a:solidFill>
+                  <a:srgbClr val="455562"/>
+                </a:solidFill>
+              </a:rPr>
+              <a:t>   /  국가 시스템 연동 범위?</a:t>
+            </a:r>
+          </a:p>
+          <a:p>
+            <a:pPr>
+              <a:spcAft>
+                <a:spcPts val="900"/>
+              </a:spcAft>
+            </a:pPr>
+            <a:r>
+              <a:rPr sz="1700">
+                <a:solidFill>
+                  <a:srgbClr val="1F2933"/>
+                </a:solidFill>
+              </a:rPr>
+              <a:t>▪ Chốt luồng phê duyệt·báo cáo nội bộ?</a:t>
+            </a:r>
+            <a:r>
+              <a:rPr sz="1500">
+                <a:solidFill>
+                  <a:srgbClr val="455562"/>
+                </a:solidFill>
+              </a:rPr>
+              <a:t>   /  내부 결재·보고 체계 확정?</a:t>
+            </a:r>
+          </a:p>
+          <a:p>
+            <a:pPr>
+              <a:spcAft>
+                <a:spcPts val="900"/>
+              </a:spcAft>
+            </a:pPr>
+            <a:r>
+              <a:rPr sz="1700">
+                <a:solidFill>
+                  <a:srgbClr val="1F2933"/>
+                </a:solidFill>
+              </a:rPr>
+              <a:t>▪ Ai đăng ký VĐV — bản thân hay tổ chức?</a:t>
+            </a:r>
+            <a:r>
+              <a:rPr sz="1500">
+                <a:solidFill>
+                  <a:srgbClr val="455562"/>
+                </a:solidFill>
+              </a:rPr>
+              <a:t>   /  경기인 등록 주체 — 본인 vs 단체?</a:t>
+            </a:r>
+          </a:p>
+          <a:p>
+            <a:pPr>
+              <a:spcAft>
+                <a:spcPts val="900"/>
+              </a:spcAft>
+            </a:pPr>
+            <a:r>
+              <a:rPr sz="1700">
+                <a:solidFill>
+                  <a:srgbClr val="1F2933"/>
+                </a:solidFill>
+              </a:rPr>
+              <a:t>▪ Căn cứ hiệu lực chữ ký điện tử?</a:t>
+            </a:r>
+            <a:r>
+              <a:rPr sz="1500">
+                <a:solidFill>
+                  <a:srgbClr val="455562"/>
+                </a:solidFill>
+              </a:rPr>
+              <a:t>   /  전자서명 효력 근거?</a:t>
+            </a:r>
+          </a:p>
+          <a:p>
+            <a:pPr>
+              <a:spcAft>
+                <a:spcPts val="900"/>
+              </a:spcAft>
+            </a:pPr>
+            <a:r>
+              <a:rPr sz="1700">
+                <a:solidFill>
+                  <a:srgbClr val="1F2933"/>
+                </a:solidFill>
+              </a:rPr>
+              <a:t>▪ Phạm vi pilot ban đầu (môn·địa phương)?</a:t>
+            </a:r>
+            <a:r>
+              <a:rPr sz="1500">
+                <a:solidFill>
+                  <a:srgbClr val="455562"/>
+                </a:solidFill>
+              </a:rPr>
+              <a:t>   /  초기 파일럿 범위(종목·지역)?</a:t>
+            </a:r>
+          </a:p>
+        </p:txBody>
+      </p:sp>
+    </p:spTree>
+  </p:cSld>
+  <p:clrMapOvr>
+    <a:masterClrMapping/>
+  </p:clrMapOvr>
+</p:sld>
+</file>
+
+<file path=ppt/slides/slide15.xml><?xml version="1.0" encoding="utf-8"?>
+<p:sld xmlns:a="http://schemas.openxmlformats.org/drawingml/2006/main" xmlns:p="http://schemas.openxmlformats.org/presentationml/2006/main" xmlns:r="http://schemas.openxmlformats.org/officeDocument/2006/relationships">
+  <p:cSld>
+    <p:bg>
+      <p:bgPr>
+        <a:solidFill>
+          <a:srgbClr val="F4F6F8"/>
+        </a:solidFill>
+        <a:effectLst/>
+      </p:bgPr>
+    </p:bg>
+    <p:spTree>
+      <p:nvGrpSpPr>
+        <p:cNvPr id="1" name=""/>
+        <p:cNvGrpSpPr/>
+        <p:nvPr/>
+      </p:nvGrpSpPr>
+      <p:grpSpPr/>
+      <p:sp>
+        <p:nvSpPr>
+          <p:cNvPr id="2" name="Rectangle 1"/>
+          <p:cNvSpPr/>
+          <p:nvPr/>
+        </p:nvSpPr>
+        <p:spPr>
+          <a:xfrm>
+            <a:off x="0" y="0"/>
+            <a:ext cx="128016" cy="6858000"/>
+          </a:xfrm>
+          <a:prstGeom prst="rect">
+            <a:avLst/>
+          </a:prstGeom>
+          <a:solidFill>
+            <a:srgbClr val="15607A"/>
+          </a:solidFill>
+          <a:ln>
+            <a:noFill/>
+          </a:ln>
+        </p:spPr>
+        <p:style>
+          <a:lnRef idx="1">
+            <a:schemeClr val="accent1"/>
+          </a:lnRef>
+          <a:fillRef idx="3">
+            <a:schemeClr val="accent1"/>
+          </a:fillRef>
+          <a:effectRef idx="2">
+            <a:schemeClr val="accent1"/>
+          </a:effectRef>
+          <a:fontRef idx="minor">
+            <a:schemeClr val="lt1"/>
+          </a:fontRef>
+        </p:style>
+        <p:txBody>
+          <a:bodyPr rtlCol="0" anchor="ctr"/>
+          <a:lstStyle/>
+          <a:p>
+            <a:pPr algn="ctr"/>
+          </a:p>
+        </p:txBody>
+      </p:sp>
+      <p:sp>
+        <p:nvSpPr>
+          <p:cNvPr id="3" name="TextBox 2"/>
+          <p:cNvSpPr txBox="1"/>
+          <p:nvPr/>
+        </p:nvSpPr>
+        <p:spPr>
+          <a:xfrm>
+            <a:off x="548640" y="411480"/>
+            <a:ext cx="11155680" cy="1051560"/>
+          </a:xfrm>
+          <a:prstGeom prst="rect">
+            <a:avLst/>
+          </a:prstGeom>
+          <a:noFill/>
+        </p:spPr>
+        <p:txBody>
+          <a:bodyPr wrap="square">
+            <a:spAutoFit/>
+          </a:bodyPr>
+          <a:lstStyle/>
+          <a:p>
+            <a:r>
+              <a:rPr sz="2800" b="1">
+                <a:solidFill>
+                  <a:srgbClr val="15607A"/>
+                </a:solidFill>
+              </a:rPr>
+              <a:t>Doanh thu · Rủi ro &amp; ứng phó</a:t>
+            </a:r>
+          </a:p>
+          <a:p>
+            <a:r>
+              <a:rPr sz="1700" b="1">
+                <a:solidFill>
+                  <a:srgbClr val="6A7C8A"/>
+                </a:solidFill>
+              </a:rPr>
+              <a:t>수익 구조 · 리스크 대응</a:t>
+            </a:r>
+          </a:p>
+        </p:txBody>
+      </p:sp>
+      <p:sp>
+        <p:nvSpPr>
+          <p:cNvPr id="4" name="TextBox 3"/>
+          <p:cNvSpPr txBox="1"/>
+          <p:nvPr/>
+        </p:nvSpPr>
+        <p:spPr>
+          <a:xfrm>
+            <a:off x="685800" y="1691640"/>
+            <a:ext cx="10881360" cy="4480560"/>
+          </a:xfrm>
+          <a:prstGeom prst="rect">
+            <a:avLst/>
+          </a:prstGeom>
+          <a:noFill/>
+        </p:spPr>
+        <p:txBody>
+          <a:bodyPr wrap="square">
+            <a:spAutoFit/>
+          </a:bodyPr>
+          <a:lstStyle/>
+          <a:p>
+            <a:pPr>
+              <a:spcAft>
+                <a:spcPts val="900"/>
+              </a:spcAft>
+            </a:pPr>
+            <a:r>
+              <a:rPr sz="1700">
+                <a:solidFill>
+                  <a:srgbClr val="1F2933"/>
+                </a:solidFill>
+              </a:rPr>
+              <a:t>▪ Doanh thu: phí hệ thống·quảng cáo/tài trợ·dịch vụ giá trị gia tăng (không trung gian dòng tiền)</a:t>
+            </a:r>
+            <a:r>
+              <a:rPr sz="1500">
+                <a:solidFill>
+                  <a:srgbClr val="455562"/>
+                </a:solidFill>
+              </a:rPr>
+              <a:t>   /  수익: 시스템 이용료·광고/후원·부가서비스(자금 미경유)</a:t>
+            </a:r>
+          </a:p>
+          <a:p>
+            <a:pPr>
+              <a:spcAft>
+                <a:spcPts val="900"/>
+              </a:spcAft>
+            </a:pPr>
+            <a:r>
+              <a:rPr sz="1700">
+                <a:solidFill>
+                  <a:srgbClr val="1F2933"/>
+                </a:solidFill>
+              </a:rPr>
+              <a:t>▪ Rủi ro biểu mẫu chậm → đề nghị ngay·chuẩn bị song song</a:t>
+            </a:r>
+            <a:r>
+              <a:rPr sz="1500">
+                <a:solidFill>
+                  <a:srgbClr val="455562"/>
+                </a:solidFill>
+              </a:rPr>
+              <a:t>   /  서식 지연 → 즉시 요청·병렬 준비</a:t>
+            </a:r>
+          </a:p>
+          <a:p>
+            <a:pPr>
+              <a:spcAft>
+                <a:spcPts val="900"/>
+              </a:spcAft>
+            </a:pPr>
+            <a:r>
+              <a:rPr sz="1700">
+                <a:solidFill>
+                  <a:srgbClr val="1F2933"/>
+                </a:solidFill>
+              </a:rPr>
+              <a:t>▪ Rủi ro pháp lý → cổng rà soát trước pilot</a:t>
+            </a:r>
+            <a:r>
+              <a:rPr sz="1500">
+                <a:solidFill>
+                  <a:srgbClr val="455562"/>
+                </a:solidFill>
+              </a:rPr>
+              <a:t>   /  법률 리스크 → 파일럿 전 검토 게이트</a:t>
+            </a:r>
+          </a:p>
+          <a:p>
+            <a:pPr>
+              <a:spcAft>
+                <a:spcPts val="900"/>
+              </a:spcAft>
+            </a:pPr>
+            <a:r>
+              <a:rPr sz="1700">
+                <a:solidFill>
+                  <a:srgbClr val="1F2933"/>
+                </a:solidFill>
+              </a:rPr>
+              <a:t>▪ Rủi ro chấp nhận → kiểm chứng bằng pilot</a:t>
+            </a:r>
+            <a:r>
+              <a:rPr sz="1500">
+                <a:solidFill>
+                  <a:srgbClr val="455562"/>
+                </a:solidFill>
+              </a:rPr>
+              <a:t>   /  채택 리스크 → 파일럿으로 검증</a:t>
+            </a:r>
+          </a:p>
+        </p:txBody>
+      </p:sp>
+    </p:spTree>
+  </p:cSld>
+  <p:clrMapOvr>
+    <a:masterClrMapping/>
+  </p:clrMapOvr>
+</p:sld>
+</file>
+
+<file path=ppt/slides/slide16.xml><?xml version="1.0" encoding="utf-8"?>
+<p:sld xmlns:a="http://schemas.openxmlformats.org/drawingml/2006/main" xmlns:p="http://schemas.openxmlformats.org/presentationml/2006/main" xmlns:r="http://schemas.openxmlformats.org/officeDocument/2006/relationships">
+  <p:cSld>
+    <p:bg>
+      <p:bgPr>
+        <a:solidFill>
+          <a:srgbClr val="F4F6F8"/>
+        </a:solidFill>
+        <a:effectLst/>
+      </p:bgPr>
+    </p:bg>
+    <p:spTree>
+      <p:nvGrpSpPr>
+        <p:cNvPr id="1" name=""/>
+        <p:cNvGrpSpPr/>
+        <p:nvPr/>
+      </p:nvGrpSpPr>
+      <p:grpSpPr/>
+      <p:sp>
+        <p:nvSpPr>
+          <p:cNvPr id="2" name="Rectangle 1"/>
+          <p:cNvSpPr/>
+          <p:nvPr/>
+        </p:nvSpPr>
+        <p:spPr>
+          <a:xfrm>
+            <a:off x="0" y="0"/>
+            <a:ext cx="128016" cy="6858000"/>
+          </a:xfrm>
+          <a:prstGeom prst="rect">
+            <a:avLst/>
+          </a:prstGeom>
+          <a:solidFill>
+            <a:srgbClr val="15607A"/>
+          </a:solidFill>
+          <a:ln>
+            <a:noFill/>
+          </a:ln>
+        </p:spPr>
+        <p:style>
+          <a:lnRef idx="1">
+            <a:schemeClr val="accent1"/>
+          </a:lnRef>
+          <a:fillRef idx="3">
+            <a:schemeClr val="accent1"/>
+          </a:fillRef>
+          <a:effectRef idx="2">
+            <a:schemeClr val="accent1"/>
+          </a:effectRef>
+          <a:fontRef idx="minor">
+            <a:schemeClr val="lt1"/>
+          </a:fontRef>
+        </p:style>
+        <p:txBody>
+          <a:bodyPr rtlCol="0" anchor="ctr"/>
+          <a:lstStyle/>
+          <a:p>
+            <a:pPr algn="ctr"/>
+          </a:p>
+        </p:txBody>
+      </p:sp>
+      <p:sp>
+        <p:nvSpPr>
+          <p:cNvPr id="3" name="TextBox 2"/>
+          <p:cNvSpPr txBox="1"/>
+          <p:nvPr/>
+        </p:nvSpPr>
+        <p:spPr>
+          <a:xfrm>
+            <a:off x="548640" y="411480"/>
+            <a:ext cx="11155680" cy="1051560"/>
+          </a:xfrm>
+          <a:prstGeom prst="rect">
+            <a:avLst/>
+          </a:prstGeom>
+          <a:noFill/>
+        </p:spPr>
+        <p:txBody>
+          <a:bodyPr wrap="square">
+            <a:spAutoFit/>
+          </a:bodyPr>
+          <a:lstStyle/>
+          <a:p>
+            <a:r>
+              <a:rPr sz="2800" b="1">
+                <a:solidFill>
+                  <a:srgbClr val="15607A"/>
+                </a:solidFill>
+              </a:rPr>
               <a:t>Hiệu quả kỳ vọng &amp; lộ trình</a:t>
             </a:r>
           </a:p>
@@ -5172,8 +6176,8 @@
         </p:nvSpPr>
         <p:spPr>
           <a:xfrm>
-            <a:off x="548640" y="411480"/>
-            <a:ext cx="11155680" cy="1051560"/>
+            <a:off x="548640" y="365760"/>
+            <a:ext cx="11155680" cy="914400"/>
           </a:xfrm>
           <a:prstGeom prst="rect">
             <a:avLst/>
@@ -5187,36 +6191,60 @@
           <a:lstStyle/>
           <a:p>
             <a:r>
-              <a:rPr sz="2800" b="1">
+              <a:rPr sz="2600" b="1">
                 <a:solidFill>
                   <a:srgbClr val="15607A"/>
                 </a:solidFill>
               </a:rPr>
-              <a:t>Kiến trúc, bảo mật &amp; tuân thủ pháp luật</a:t>
-            </a:r>
-          </a:p>
-          <a:p>
-            <a:r>
-              <a:rPr sz="1700" b="1">
+              <a:t>Màn hình thực tế — Cổng công khai (1)</a:t>
+            </a:r>
+          </a:p>
+          <a:p>
+            <a:r>
+              <a:rPr sz="1500" b="1">
                 <a:solidFill>
                   <a:srgbClr val="6A7C8A"/>
                 </a:solidFill>
               </a:rPr>
-              <a:t>시스템·보안·법규 준수</a:t>
-            </a:r>
-          </a:p>
-        </p:txBody>
-      </p:sp>
-      <p:sp>
-        <p:nvSpPr>
-          <p:cNvPr id="4" name="TextBox 3"/>
+              <a:t>실제 화면 — 대외 공개웹 (1)</a:t>
+            </a:r>
+          </a:p>
+        </p:txBody>
+      </p:sp>
+      <p:pic>
+        <p:nvPicPr>
+          <p:cNvPr id="4" name="Picture 3" descr="01-home.png"/>
+          <p:cNvPicPr>
+            <a:picLocks noChangeAspect="1"/>
+          </p:cNvPicPr>
+          <p:nvPr/>
+        </p:nvPicPr>
+        <p:blipFill>
+          <a:blip r:embed="rId2"/>
+          <a:stretch>
+            <a:fillRect/>
+          </a:stretch>
+        </p:blipFill>
+        <p:spPr>
+          <a:xfrm>
+            <a:off x="2265660" y="1554480"/>
+            <a:ext cx="1960919" cy="4069079"/>
+          </a:xfrm>
+          <a:prstGeom prst="rect">
+            <a:avLst/>
+          </a:prstGeom>
+        </p:spPr>
+      </p:pic>
+      <p:sp>
+        <p:nvSpPr>
+          <p:cNvPr id="5" name="TextBox 4"/>
           <p:cNvSpPr txBox="1"/>
           <p:nvPr/>
         </p:nvSpPr>
         <p:spPr>
           <a:xfrm>
-            <a:off x="685800" y="1691640"/>
-            <a:ext cx="10881360" cy="4480560"/>
+            <a:off x="457200" y="5806440"/>
+            <a:ext cx="5577840" cy="777240"/>
           </a:xfrm>
           <a:prstGeom prst="rect">
             <a:avLst/>
@@ -5229,118 +6257,94 @@
           </a:bodyPr>
           <a:lstStyle/>
           <a:p>
-            <a:pPr>
-              <a:spcAft>
-                <a:spcPts val="900"/>
-              </a:spcAft>
-            </a:pPr>
-            <a:r>
-              <a:rPr sz="1700">
+            <a:pPr algn="ctr"/>
+            <a:r>
+              <a:rPr sz="1300" b="1">
                 <a:solidFill>
                   <a:srgbClr val="1F2933"/>
                 </a:solidFill>
               </a:rPr>
-              <a:t>▪ Tách dữ liệu công khai/nghiệp vụ (pub + vai trò chỉ-đọc)</a:t>
-            </a:r>
-            <a:r>
-              <a:rPr sz="1500">
+              <a:t>Trang chủ</a:t>
+            </a:r>
+          </a:p>
+          <a:p>
+            <a:pPr algn="ctr"/>
+            <a:r>
+              <a:rPr sz="1100">
                 <a:solidFill>
                   <a:srgbClr val="455562"/>
                 </a:solidFill>
               </a:rPr>
-              <a:t>   /  대외/업무 데이터 분리(pub+읽기전용 롤)</a:t>
-            </a:r>
-          </a:p>
-          <a:p>
-            <a:pPr>
-              <a:spcAft>
-                <a:spcPts val="900"/>
-              </a:spcAft>
-            </a:pPr>
-            <a:r>
-              <a:rPr sz="1700">
+              <a:t>홈</a:t>
+            </a:r>
+          </a:p>
+        </p:txBody>
+      </p:sp>
+      <p:pic>
+        <p:nvPicPr>
+          <p:cNvPr id="6" name="Picture 5" descr="03-match-record.png"/>
+          <p:cNvPicPr>
+            <a:picLocks noChangeAspect="1"/>
+          </p:cNvPicPr>
+          <p:nvPr/>
+        </p:nvPicPr>
+        <p:blipFill>
+          <a:blip r:embed="rId3"/>
+          <a:stretch>
+            <a:fillRect/>
+          </a:stretch>
+        </p:blipFill>
+        <p:spPr>
+          <a:xfrm>
+            <a:off x="6423660" y="1554480"/>
+            <a:ext cx="5349240" cy="3343275"/>
+          </a:xfrm>
+          <a:prstGeom prst="rect">
+            <a:avLst/>
+          </a:prstGeom>
+        </p:spPr>
+      </p:pic>
+      <p:sp>
+        <p:nvSpPr>
+          <p:cNvPr id="7" name="TextBox 6"/>
+          <p:cNvSpPr txBox="1"/>
+          <p:nvPr/>
+        </p:nvSpPr>
+        <p:spPr>
+          <a:xfrm>
+            <a:off x="6309360" y="5806440"/>
+            <a:ext cx="5577840" cy="777240"/>
+          </a:xfrm>
+          <a:prstGeom prst="rect">
+            <a:avLst/>
+          </a:prstGeom>
+          <a:noFill/>
+        </p:spPr>
+        <p:txBody>
+          <a:bodyPr wrap="square">
+            <a:spAutoFit/>
+          </a:bodyPr>
+          <a:lstStyle/>
+          <a:p>
+            <a:pPr algn="ctr"/>
+            <a:r>
+              <a:rPr sz="1300" b="1">
                 <a:solidFill>
                   <a:srgbClr val="1F2933"/>
                 </a:solidFill>
               </a:rPr>
-              <a:t>▪ Bảo vệ dữ liệu cá nhân (NĐ 13/2023): năm sinh·trẻ vị thành niên·băm giấy tờ</a:t>
-            </a:r>
-            <a:r>
-              <a:rPr sz="1500">
+              <a:t>Chi tiết trận đấu</a:t>
+            </a:r>
+          </a:p>
+          <a:p>
+            <a:pPr algn="ctr"/>
+            <a:r>
+              <a:rPr sz="1100">
                 <a:solidFill>
                   <a:srgbClr val="455562"/>
                 </a:solidFill>
               </a:rPr>
-              <a:t>   /  개인정보(13/2023): 출생연도·미성년·신분증 해시</a:t>
-            </a:r>
-          </a:p>
-          <a:p>
-            <a:pPr>
-              <a:spcAft>
-                <a:spcPts val="900"/>
-              </a:spcAft>
-            </a:pPr>
-            <a:r>
-              <a:rPr sz="1700">
-                <a:solidFill>
-                  <a:srgbClr val="1F2933"/>
-                </a:solidFill>
-              </a:rPr>
-              <a:t>▪ Nội địa hóa dữ liệu (NĐ 53/2022): máy chủ trong nước</a:t>
-            </a:r>
-            <a:r>
-              <a:rPr sz="1500">
-                <a:solidFill>
-                  <a:srgbClr val="455562"/>
-                </a:solidFill>
-              </a:rPr>
-              <a:t>   /  데이터 현지화(53/2022): 국내 서버</a:t>
-            </a:r>
-          </a:p>
-          <a:p>
-            <a:pPr>
-              <a:spcAft>
-                <a:spcPts val="900"/>
-              </a:spcAft>
-            </a:pPr>
-            <a:r>
-              <a:rPr sz="1700">
-                <a:solidFill>
-                  <a:srgbClr val="1F2933"/>
-                </a:solidFill>
-              </a:rPr>
-              <a:t>▪ Thanh toán (NĐ 52/2024): tiền không qua tài khoản chúng tôi</a:t>
-            </a:r>
-            <a:r>
-              <a:rPr sz="1500">
-                <a:solidFill>
-                  <a:srgbClr val="455562"/>
-                </a:solidFill>
-              </a:rPr>
-              <a:t>   /  결제(52/2024): 자금 우리 계좌 미경유</a:t>
-            </a:r>
-          </a:p>
-          <a:p>
-            <a:pPr>
-              <a:spcAft>
-                <a:spcPts val="900"/>
-              </a:spcAft>
-            </a:pPr>
-            <a:r>
-              <a:rPr sz="1700">
-                <a:solidFill>
-                  <a:srgbClr val="1F2933"/>
-                </a:solidFill>
-              </a:rPr>
-              <a:t>▪ Xác nhận hiệu lực chữ ký điện tử của phê duyệt</a:t>
-            </a:r>
-            <a:r>
-              <a:rPr sz="1500">
-                <a:solidFill>
-                  <a:srgbClr val="455562"/>
-                </a:solidFill>
-              </a:rPr>
-              <a:t>   /  전자결재 법적 효력 근거 확인</a:t>
+              <a:t>경기 상세</a:t>
             </a:r>
           </a:p>
         </p:txBody>
@@ -5422,8 +6426,8 @@
         </p:nvSpPr>
         <p:spPr>
           <a:xfrm>
-            <a:off x="548640" y="411480"/>
-            <a:ext cx="11155680" cy="1051560"/>
+            <a:off x="548640" y="365760"/>
+            <a:ext cx="11155680" cy="914400"/>
           </a:xfrm>
           <a:prstGeom prst="rect">
             <a:avLst/>
@@ -5437,36 +6441,60 @@
           <a:lstStyle/>
           <a:p>
             <a:r>
-              <a:rPr sz="2800" b="1">
+              <a:rPr sz="2600" b="1">
                 <a:solidFill>
                   <a:srgbClr val="15607A"/>
                 </a:solidFill>
               </a:rPr>
-              <a:t>Điều kiện vận hành: 4 cửa &amp; lộ trình</a:t>
-            </a:r>
-          </a:p>
-          <a:p>
-            <a:r>
-              <a:rPr sz="1700" b="1">
+              <a:t>Màn hình thực tế — Cổng công khai (2)</a:t>
+            </a:r>
+          </a:p>
+          <a:p>
+            <a:r>
+              <a:rPr sz="1500" b="1">
                 <a:solidFill>
                   <a:srgbClr val="6A7C8A"/>
                 </a:solidFill>
               </a:rPr>
-              <a:t>실사용: 4관문 &amp; 로드맵</a:t>
-            </a:r>
-          </a:p>
-        </p:txBody>
-      </p:sp>
-      <p:sp>
-        <p:nvSpPr>
-          <p:cNvPr id="4" name="TextBox 3"/>
+              <a:t>실제 화면 — 대외 공개웹 (2)</a:t>
+            </a:r>
+          </a:p>
+        </p:txBody>
+      </p:sp>
+      <p:pic>
+        <p:nvPicPr>
+          <p:cNvPr id="4" name="Picture 3" descr="05-rankings.png"/>
+          <p:cNvPicPr>
+            <a:picLocks noChangeAspect="1"/>
+          </p:cNvPicPr>
+          <p:nvPr/>
+        </p:nvPicPr>
+        <p:blipFill>
+          <a:blip r:embed="rId2"/>
+          <a:stretch>
+            <a:fillRect/>
+          </a:stretch>
+        </p:blipFill>
+        <p:spPr>
+          <a:xfrm>
+            <a:off x="571500" y="1554480"/>
+            <a:ext cx="5349240" cy="3343275"/>
+          </a:xfrm>
+          <a:prstGeom prst="rect">
+            <a:avLst/>
+          </a:prstGeom>
+        </p:spPr>
+      </p:pic>
+      <p:sp>
+        <p:nvSpPr>
+          <p:cNvPr id="5" name="TextBox 4"/>
           <p:cNvSpPr txBox="1"/>
           <p:nvPr/>
         </p:nvSpPr>
         <p:spPr>
           <a:xfrm>
-            <a:off x="685800" y="1691640"/>
-            <a:ext cx="10881360" cy="4480560"/>
+            <a:off x="457200" y="5806440"/>
+            <a:ext cx="5577840" cy="777240"/>
           </a:xfrm>
           <a:prstGeom prst="rect">
             <a:avLst/>
@@ -5479,118 +6507,94 @@
           </a:bodyPr>
           <a:lstStyle/>
           <a:p>
-            <a:pPr>
-              <a:spcAft>
-                <a:spcPts val="900"/>
-              </a:spcAft>
-            </a:pPr>
-            <a:r>
-              <a:rPr sz="1700">
+            <a:pPr algn="ctr"/>
+            <a:r>
+              <a:rPr sz="1300" b="1">
                 <a:solidFill>
                   <a:srgbClr val="1F2933"/>
                 </a:solidFill>
               </a:rPr>
-              <a:t>▪ Cửa 1 Pháp lý · Cửa 2 Dữ liệu/biểu mẫu · Cửa 3 Hạ tầng/khóa · Cửa 4 Vận hành</a:t>
-            </a:r>
-            <a:r>
-              <a:rPr sz="1500">
+              <a:t>Bảng xếp hạng</a:t>
+            </a:r>
+          </a:p>
+          <a:p>
+            <a:pPr algn="ctr"/>
+            <a:r>
+              <a:rPr sz="1100">
                 <a:solidFill>
                   <a:srgbClr val="455562"/>
                 </a:solidFill>
               </a:rPr>
-              <a:t>   /  관문1 법·2 데이터/서식·3 인프라/키·4 운영</a:t>
-            </a:r>
-          </a:p>
-          <a:p>
-            <a:pPr>
-              <a:spcAft>
-                <a:spcPts val="900"/>
-              </a:spcAft>
-            </a:pPr>
-            <a:r>
-              <a:rPr sz="1700">
+              <a:t>순위판</a:t>
+            </a:r>
+          </a:p>
+        </p:txBody>
+      </p:sp>
+      <p:pic>
+        <p:nvPicPr>
+          <p:cNvPr id="6" name="Picture 5" descr="06-sponsorship.png"/>
+          <p:cNvPicPr>
+            <a:picLocks noChangeAspect="1"/>
+          </p:cNvPicPr>
+          <p:nvPr/>
+        </p:nvPicPr>
+        <p:blipFill>
+          <a:blip r:embed="rId3"/>
+          <a:stretch>
+            <a:fillRect/>
+          </a:stretch>
+        </p:blipFill>
+        <p:spPr>
+          <a:xfrm>
+            <a:off x="6423660" y="1554480"/>
+            <a:ext cx="5349240" cy="3343275"/>
+          </a:xfrm>
+          <a:prstGeom prst="rect">
+            <a:avLst/>
+          </a:prstGeom>
+        </p:spPr>
+      </p:pic>
+      <p:sp>
+        <p:nvSpPr>
+          <p:cNvPr id="7" name="TextBox 6"/>
+          <p:cNvSpPr txBox="1"/>
+          <p:nvPr/>
+        </p:nvSpPr>
+        <p:spPr>
+          <a:xfrm>
+            <a:off x="6309360" y="5806440"/>
+            <a:ext cx="5577840" cy="777240"/>
+          </a:xfrm>
+          <a:prstGeom prst="rect">
+            <a:avLst/>
+          </a:prstGeom>
+          <a:noFill/>
+        </p:spPr>
+        <p:txBody>
+          <a:bodyPr wrap="square">
+            <a:spAutoFit/>
+          </a:bodyPr>
+          <a:lstStyle/>
+          <a:p>
+            <a:pPr algn="ctr"/>
+            <a:r>
+              <a:rPr sz="1300" b="1">
                 <a:solidFill>
                   <a:srgbClr val="1F2933"/>
                 </a:solidFill>
               </a:rPr>
-              <a:t>▪ P0 Họp(nay): demo·câu hỏi quyết định</a:t>
-            </a:r>
-            <a:r>
-              <a:rPr sz="1500">
+              <a:t>Tài trợ</a:t>
+            </a:r>
+          </a:p>
+          <a:p>
+            <a:pPr algn="ctr"/>
+            <a:r>
+              <a:rPr sz="1100">
                 <a:solidFill>
                   <a:srgbClr val="455562"/>
                 </a:solidFill>
               </a:rPr>
-              <a:t>   /  P0 미팅(지금): 데모·확인질문</a:t>
-            </a:r>
-          </a:p>
-          <a:p>
-            <a:pPr>
-              <a:spcAft>
-                <a:spcPts val="900"/>
-              </a:spcAft>
-            </a:pPr>
-            <a:r>
-              <a:rPr sz="1700">
-                <a:solidFill>
-                  <a:srgbClr val="1F2933"/>
-                </a:solidFill>
-              </a:rPr>
-              <a:t>▪ P1 (1–2 tuần): phản ánh biểu mẫu·nạp khóa·staging VN·diễn tập</a:t>
-            </a:r>
-            <a:r>
-              <a:rPr sz="1500">
-                <a:solidFill>
-                  <a:srgbClr val="455562"/>
-                </a:solidFill>
-              </a:rPr>
-              <a:t>   /  P1(1–2주): 서식반영·키·VN 스테이징·리허설</a:t>
-            </a:r>
-          </a:p>
-          <a:p>
-            <a:pPr>
-              <a:spcAft>
-                <a:spcPts val="900"/>
-              </a:spcAft>
-            </a:pPr>
-            <a:r>
-              <a:rPr sz="1700">
-                <a:solidFill>
-                  <a:srgbClr val="1F2933"/>
-                </a:solidFill>
-              </a:rPr>
-              <a:t>▪ P2 (4–8 tuần): pilot 1 môn·1 địa phương → qua cổng pháp lý</a:t>
-            </a:r>
-            <a:r>
-              <a:rPr sz="1500">
-                <a:solidFill>
-                  <a:srgbClr val="455562"/>
-                </a:solidFill>
-              </a:rPr>
-              <a:t>   /  P2(4–8주): 1종목·1지역 파일럿 → 법률 게이트 통과</a:t>
-            </a:r>
-          </a:p>
-          <a:p>
-            <a:pPr>
-              <a:spcAft>
-                <a:spcPts val="900"/>
-              </a:spcAft>
-            </a:pPr>
-            <a:r>
-              <a:rPr sz="1700">
-                <a:solidFill>
-                  <a:srgbClr val="1F2933"/>
-                </a:solidFill>
-              </a:rPr>
-              <a:t>▪ P3: mở rộng toàn quốc·toàn môn·mở cổng công khai</a:t>
-            </a:r>
-            <a:r>
-              <a:rPr sz="1500">
-                <a:solidFill>
-                  <a:srgbClr val="455562"/>
-                </a:solidFill>
-              </a:rPr>
-              <a:t>   /  P3: 전국·전종목·공개 확대</a:t>
+              <a:t>후원</a:t>
             </a:r>
           </a:p>
         </p:txBody>
@@ -5672,8 +6676,8 @@
         </p:nvSpPr>
         <p:spPr>
           <a:xfrm>
-            <a:off x="548640" y="411480"/>
-            <a:ext cx="11155680" cy="1051560"/>
+            <a:off x="548640" y="365760"/>
+            <a:ext cx="11155680" cy="914400"/>
           </a:xfrm>
           <a:prstGeom prst="rect">
             <a:avLst/>
@@ -5687,36 +6691,60 @@
           <a:lstStyle/>
           <a:p>
             <a:r>
-              <a:rPr sz="2800" b="1">
+              <a:rPr sz="2600" b="1">
                 <a:solidFill>
                   <a:srgbClr val="15607A"/>
                 </a:solidFill>
               </a:rPr>
-              <a:t>Đề nghị với Bộ VHTTDL / Cục TDTT</a:t>
-            </a:r>
-          </a:p>
-          <a:p>
-            <a:r>
-              <a:rPr sz="1700" b="1">
+              <a:t>Màn hình thực tế — Khu nghiệp vụ (1)</a:t>
+            </a:r>
+          </a:p>
+          <a:p>
+            <a:r>
+              <a:rPr sz="1500" b="1">
                 <a:solidFill>
                   <a:srgbClr val="6A7C8A"/>
                 </a:solidFill>
               </a:rPr>
-              <a:t>문체부·체육회 요청 (미팅 핵심)</a:t>
-            </a:r>
-          </a:p>
-        </p:txBody>
-      </p:sp>
-      <p:sp>
-        <p:nvSpPr>
-          <p:cNvPr id="4" name="TextBox 3"/>
+              <a:t>실제 화면 — 업무 (1)</a:t>
+            </a:r>
+          </a:p>
+        </p:txBody>
+      </p:sp>
+      <p:pic>
+        <p:nvPicPr>
+          <p:cNvPr id="4" name="Picture 3" descr="08-admin-dashboard.png"/>
+          <p:cNvPicPr>
+            <a:picLocks noChangeAspect="1"/>
+          </p:cNvPicPr>
+          <p:nvPr/>
+        </p:nvPicPr>
+        <p:blipFill>
+          <a:blip r:embed="rId2"/>
+          <a:stretch>
+            <a:fillRect/>
+          </a:stretch>
+        </p:blipFill>
+        <p:spPr>
+          <a:xfrm>
+            <a:off x="653407" y="1554480"/>
+            <a:ext cx="5185425" cy="4069080"/>
+          </a:xfrm>
+          <a:prstGeom prst="rect">
+            <a:avLst/>
+          </a:prstGeom>
+        </p:spPr>
+      </p:pic>
+      <p:sp>
+        <p:nvSpPr>
+          <p:cNvPr id="5" name="TextBox 4"/>
           <p:cNvSpPr txBox="1"/>
           <p:nvPr/>
         </p:nvSpPr>
         <p:spPr>
           <a:xfrm>
-            <a:off x="685800" y="1691640"/>
-            <a:ext cx="10881360" cy="4480560"/>
+            <a:off x="457200" y="5806440"/>
+            <a:ext cx="5577840" cy="777240"/>
           </a:xfrm>
           <a:prstGeom prst="rect">
             <a:avLst/>
@@ -5729,118 +6757,94 @@
           </a:bodyPr>
           <a:lstStyle/>
           <a:p>
-            <a:pPr>
-              <a:spcAft>
-                <a:spcPts val="900"/>
-              </a:spcAft>
-            </a:pPr>
-            <a:r>
-              <a:rPr sz="1700">
+            <a:pPr algn="ctr"/>
+            <a:r>
+              <a:rPr sz="1300" b="1">
                 <a:solidFill>
                   <a:srgbClr val="1F2933"/>
                 </a:solidFill>
               </a:rPr>
-              <a:t>▪ Biểu mẫu chính thức (Word/Excel) — nút thắt LỚN NHẤT</a:t>
-            </a:r>
-            <a:r>
-              <a:rPr sz="1500">
+              <a:t>Bảng điều khiển</a:t>
+            </a:r>
+          </a:p>
+          <a:p>
+            <a:pPr algn="ctr"/>
+            <a:r>
+              <a:rPr sz="1100">
                 <a:solidFill>
                   <a:srgbClr val="455562"/>
                 </a:solidFill>
               </a:rPr>
-              <a:t>   /  공식 서식(Word/Excel) — 최대 병목</a:t>
-            </a:r>
-          </a:p>
-          <a:p>
-            <a:pPr>
-              <a:spcAft>
-                <a:spcPts val="900"/>
-              </a:spcAft>
-            </a:pPr>
-            <a:r>
-              <a:rPr sz="1700">
+              <a:t>대시보드</a:t>
+            </a:r>
+          </a:p>
+        </p:txBody>
+      </p:sp>
+      <p:pic>
+        <p:nvPicPr>
+          <p:cNvPr id="6" name="Picture 5" descr="10-admin-ingest-review.png"/>
+          <p:cNvPicPr>
+            <a:picLocks noChangeAspect="1"/>
+          </p:cNvPicPr>
+          <p:nvPr/>
+        </p:nvPicPr>
+        <p:blipFill>
+          <a:blip r:embed="rId3"/>
+          <a:stretch>
+            <a:fillRect/>
+          </a:stretch>
+        </p:blipFill>
+        <p:spPr>
+          <a:xfrm>
+            <a:off x="6423660" y="1554480"/>
+            <a:ext cx="5349240" cy="3343275"/>
+          </a:xfrm>
+          <a:prstGeom prst="rect">
+            <a:avLst/>
+          </a:prstGeom>
+        </p:spPr>
+      </p:pic>
+      <p:sp>
+        <p:nvSpPr>
+          <p:cNvPr id="7" name="TextBox 6"/>
+          <p:cNvSpPr txBox="1"/>
+          <p:nvPr/>
+        </p:nvSpPr>
+        <p:spPr>
+          <a:xfrm>
+            <a:off x="6309360" y="5806440"/>
+            <a:ext cx="5577840" cy="777240"/>
+          </a:xfrm>
+          <a:prstGeom prst="rect">
+            <a:avLst/>
+          </a:prstGeom>
+          <a:noFill/>
+        </p:spPr>
+        <p:txBody>
+          <a:bodyPr wrap="square">
+            <a:spAutoFit/>
+          </a:bodyPr>
+          <a:lstStyle/>
+          <a:p>
+            <a:pPr algn="ctr"/>
+            <a:r>
+              <a:rPr sz="1300" b="1">
                 <a:solidFill>
                   <a:srgbClr val="1F2933"/>
                 </a:solidFill>
               </a:rPr>
-              <a:t>▪ 34 mã tỉnh/thành hành chính chính thức</a:t>
-            </a:r>
-            <a:r>
-              <a:rPr sz="1500">
+              <a:t>AI duyệt hồ sơ</a:t>
+            </a:r>
+          </a:p>
+          <a:p>
+            <a:pPr algn="ctr"/>
+            <a:r>
+              <a:rPr sz="1100">
                 <a:solidFill>
                   <a:srgbClr val="455562"/>
                 </a:solidFill>
               </a:rPr>
-              <a:t>   /  공식 34개 성/시 코드</a:t>
-            </a:r>
-          </a:p>
-          <a:p>
-            <a:pPr>
-              <a:spcAft>
-                <a:spcPts val="900"/>
-              </a:spcAft>
-            </a:pPr>
-            <a:r>
-              <a:rPr sz="1700">
-                <a:solidFill>
-                  <a:srgbClr val="1F2933"/>
-                </a:solidFill>
-              </a:rPr>
-              <a:t>▪ Luồng phê duyệt &amp; thời hạn pháp định theo thủ tục</a:t>
-            </a:r>
-            <a:r>
-              <a:rPr sz="1500">
-                <a:solidFill>
-                  <a:srgbClr val="455562"/>
-                </a:solidFill>
-              </a:rPr>
-              <a:t>   /  절차별 결재선·법정기한</a:t>
-            </a:r>
-          </a:p>
-          <a:p>
-            <a:pPr>
-              <a:spcAft>
-                <a:spcPts val="900"/>
-              </a:spcAft>
-            </a:pPr>
-            <a:r>
-              <a:rPr sz="1700">
-                <a:solidFill>
-                  <a:srgbClr val="1F2933"/>
-                </a:solidFill>
-              </a:rPr>
-              <a:t>▪ Phạm vi kết nối hệ thống QG (DVC·VNeID·văn bản/chữ ký)</a:t>
-            </a:r>
-            <a:r>
-              <a:rPr sz="1500">
-                <a:solidFill>
-                  <a:srgbClr val="455562"/>
-                </a:solidFill>
-              </a:rPr>
-              <a:t>   /  국가시스템 연동 범위(포털·VNeID·전자문서)</a:t>
-            </a:r>
-          </a:p>
-          <a:p>
-            <a:pPr>
-              <a:spcAft>
-                <a:spcPts val="900"/>
-              </a:spcAft>
-            </a:pPr>
-            <a:r>
-              <a:rPr sz="1700">
-                <a:solidFill>
-                  <a:srgbClr val="1F2933"/>
-                </a:solidFill>
-              </a:rPr>
-              <a:t>▪ Căn cứ pháp lý: chữ ký điện tử·dữ liệu·thanh toán</a:t>
-            </a:r>
-            <a:r>
-              <a:rPr sz="1500">
-                <a:solidFill>
-                  <a:srgbClr val="455562"/>
-                </a:solidFill>
-              </a:rPr>
-              <a:t>   /  법적 근거: 전자서명·개인정보·결제</a:t>
+              <a:t>AI 서류 검토·확정</a:t>
             </a:r>
           </a:p>
         </p:txBody>

</xml_diff>